<commit_message>
AVANCES PARA EL REPORTE DE PPMS DE CERTIFICACION
</commit_message>
<xml_diff>
--- a/60_PPM'S_CERTIFICACION/Docs/IT_DEV_PPMS_CERTIFICACION_REPORT.pptx
+++ b/60_PPM'S_CERTIFICACION/Docs/IT_DEV_PPMS_CERTIFICACION_REPORT.pptx
@@ -5,11 +5,13 @@
     <p:sldMasterId id="2147483648" r:id="rId1"/>
   </p:sldMasterIdLst>
   <p:notesMasterIdLst>
-    <p:notesMasterId r:id="rId4"/>
+    <p:notesMasterId r:id="rId6"/>
   </p:notesMasterIdLst>
   <p:sldIdLst>
     <p:sldId id="397" r:id="rId2"/>
-    <p:sldId id="418" r:id="rId3"/>
+    <p:sldId id="420" r:id="rId3"/>
+    <p:sldId id="419" r:id="rId4"/>
+    <p:sldId id="418" r:id="rId5"/>
   </p:sldIdLst>
   <p:sldSz cx="9144000" cy="6858000" type="screen4x3"/>
   <p:notesSz cx="6858000" cy="9144000"/>
@@ -209,7 +211,7 @@
           <a:p>
             <a:fld id="{A17B1792-3256-4E77-8442-3E205CD69EF5}" type="datetimeFigureOut">
               <a:rPr lang="en-US" smtClean="0"/>
-              <a:t>9/27/2021</a:t>
+              <a:t>10/11/2021</a:t>
             </a:fld>
             <a:endParaRPr lang="en-US"/>
           </a:p>
@@ -655,7 +657,7 @@
           <a:p>
             <a:fld id="{07558649-2619-44F9-8F30-2D6466E57529}" type="datetimeFigureOut">
               <a:rPr lang="en-US" smtClean="0"/>
-              <a:t>9/27/2021</a:t>
+              <a:t>10/11/2021</a:t>
             </a:fld>
             <a:endParaRPr lang="en-US"/>
           </a:p>
@@ -823,7 +825,7 @@
           <a:p>
             <a:fld id="{07558649-2619-44F9-8F30-2D6466E57529}" type="datetimeFigureOut">
               <a:rPr lang="en-US" smtClean="0"/>
-              <a:t>9/27/2021</a:t>
+              <a:t>10/11/2021</a:t>
             </a:fld>
             <a:endParaRPr lang="en-US"/>
           </a:p>
@@ -1001,7 +1003,7 @@
           <a:p>
             <a:fld id="{07558649-2619-44F9-8F30-2D6466E57529}" type="datetimeFigureOut">
               <a:rPr lang="en-US" smtClean="0"/>
-              <a:t>9/27/2021</a:t>
+              <a:t>10/11/2021</a:t>
             </a:fld>
             <a:endParaRPr lang="en-US"/>
           </a:p>
@@ -1169,7 +1171,7 @@
           <a:p>
             <a:fld id="{07558649-2619-44F9-8F30-2D6466E57529}" type="datetimeFigureOut">
               <a:rPr lang="en-US" smtClean="0"/>
-              <a:t>9/27/2021</a:t>
+              <a:t>10/11/2021</a:t>
             </a:fld>
             <a:endParaRPr lang="en-US"/>
           </a:p>
@@ -1414,7 +1416,7 @@
           <a:p>
             <a:fld id="{07558649-2619-44F9-8F30-2D6466E57529}" type="datetimeFigureOut">
               <a:rPr lang="en-US" smtClean="0"/>
-              <a:t>9/27/2021</a:t>
+              <a:t>10/11/2021</a:t>
             </a:fld>
             <a:endParaRPr lang="en-US"/>
           </a:p>
@@ -1699,7 +1701,7 @@
           <a:p>
             <a:fld id="{07558649-2619-44F9-8F30-2D6466E57529}" type="datetimeFigureOut">
               <a:rPr lang="en-US" smtClean="0"/>
-              <a:t>9/27/2021</a:t>
+              <a:t>10/11/2021</a:t>
             </a:fld>
             <a:endParaRPr lang="en-US"/>
           </a:p>
@@ -2118,7 +2120,7 @@
           <a:p>
             <a:fld id="{07558649-2619-44F9-8F30-2D6466E57529}" type="datetimeFigureOut">
               <a:rPr lang="en-US" smtClean="0"/>
-              <a:t>9/27/2021</a:t>
+              <a:t>10/11/2021</a:t>
             </a:fld>
             <a:endParaRPr lang="en-US"/>
           </a:p>
@@ -2235,7 +2237,7 @@
           <a:p>
             <a:fld id="{07558649-2619-44F9-8F30-2D6466E57529}" type="datetimeFigureOut">
               <a:rPr lang="en-US" smtClean="0"/>
-              <a:t>9/27/2021</a:t>
+              <a:t>10/11/2021</a:t>
             </a:fld>
             <a:endParaRPr lang="en-US"/>
           </a:p>
@@ -2330,7 +2332,7 @@
           <a:p>
             <a:fld id="{07558649-2619-44F9-8F30-2D6466E57529}" type="datetimeFigureOut">
               <a:rPr lang="en-US" smtClean="0"/>
-              <a:t>9/27/2021</a:t>
+              <a:t>10/11/2021</a:t>
             </a:fld>
             <a:endParaRPr lang="en-US"/>
           </a:p>
@@ -2605,7 +2607,7 @@
           <a:p>
             <a:fld id="{07558649-2619-44F9-8F30-2D6466E57529}" type="datetimeFigureOut">
               <a:rPr lang="en-US" smtClean="0"/>
-              <a:t>9/27/2021</a:t>
+              <a:t>10/11/2021</a:t>
             </a:fld>
             <a:endParaRPr lang="en-US"/>
           </a:p>
@@ -2857,7 +2859,7 @@
           <a:p>
             <a:fld id="{07558649-2619-44F9-8F30-2D6466E57529}" type="datetimeFigureOut">
               <a:rPr lang="en-US" smtClean="0"/>
-              <a:t>9/27/2021</a:t>
+              <a:t>10/11/2021</a:t>
             </a:fld>
             <a:endParaRPr lang="en-US"/>
           </a:p>
@@ -3077,7 +3079,7 @@
           <a:p>
             <a:fld id="{07558649-2619-44F9-8F30-2D6466E57529}" type="datetimeFigureOut">
               <a:rPr lang="en-US" smtClean="0"/>
-              <a:t>9/27/2021</a:t>
+              <a:t>10/11/2021</a:t>
             </a:fld>
             <a:endParaRPr lang="en-US"/>
           </a:p>
@@ -3494,7 +3496,7 @@
               <a:rPr lang="es-MX" b="1" dirty="0">
                 <a:latin typeface="Century Gothic" panose="020B0502020202020204" pitchFamily="34" charset="0"/>
               </a:rPr>
-              <a:t>20/09/2021 – 24/09/2021</a:t>
+              <a:t>04/10/2021 – 08/10/2021</a:t>
             </a:r>
             <a:endParaRPr lang="es-MX" dirty="0">
               <a:latin typeface="Century Gothic" panose="020B0502020202020204" pitchFamily="34" charset="0"/>
@@ -3516,6 +3518,454 @@
 </file>
 
 <file path=ppt/slides/slide2.xml><?xml version="1.0" encoding="utf-8"?>
+<p:sld xmlns:a="http://schemas.openxmlformats.org/drawingml/2006/main" xmlns:r="http://schemas.openxmlformats.org/officeDocument/2006/relationships" xmlns:p="http://schemas.openxmlformats.org/presentationml/2006/main">
+  <p:cSld>
+    <p:spTree>
+      <p:nvGrpSpPr>
+        <p:cNvPr id="1" name=""/>
+        <p:cNvGrpSpPr/>
+        <p:nvPr/>
+      </p:nvGrpSpPr>
+      <p:grpSpPr>
+        <a:xfrm>
+          <a:off x="0" y="0"/>
+          <a:ext cx="0" cy="0"/>
+          <a:chOff x="0" y="0"/>
+          <a:chExt cx="0" cy="0"/>
+        </a:xfrm>
+      </p:grpSpPr>
+      <p:sp>
+        <p:nvSpPr>
+          <p:cNvPr id="8" name="Title 1"/>
+          <p:cNvSpPr txBox="1">
+            <a:spLocks/>
+          </p:cNvSpPr>
+          <p:nvPr/>
+        </p:nvSpPr>
+        <p:spPr>
+          <a:xfrm>
+            <a:off x="1087408" y="274638"/>
+            <a:ext cx="7229008" cy="634082"/>
+          </a:xfrm>
+          <a:prstGeom prst="rect">
+            <a:avLst/>
+          </a:prstGeom>
+        </p:spPr>
+        <p:txBody>
+          <a:bodyPr/>
+          <a:lstStyle>
+            <a:lvl1pPr algn="ctr" defTabSz="914400" rtl="0" eaLnBrk="1" latinLnBrk="0" hangingPunct="1">
+              <a:spcBef>
+                <a:spcPct val="0"/>
+              </a:spcBef>
+              <a:buNone/>
+              <a:defRPr sz="4400" kern="1200">
+                <a:solidFill>
+                  <a:schemeClr val="tx1"/>
+                </a:solidFill>
+                <a:latin typeface="+mj-lt"/>
+                <a:ea typeface="+mj-ea"/>
+                <a:cs typeface="+mj-cs"/>
+              </a:defRPr>
+            </a:lvl1pPr>
+          </a:lstStyle>
+          <a:p>
+            <a:pPr algn="l"/>
+            <a:r>
+              <a:rPr lang="es-ES" sz="2000" dirty="0">
+                <a:solidFill>
+                  <a:srgbClr val="3F1900"/>
+                </a:solidFill>
+              </a:rPr>
+              <a:t>QC: Pantalla Certification Report.</a:t>
+            </a:r>
+            <a:endParaRPr lang="en-US" sz="2000" dirty="0">
+              <a:solidFill>
+                <a:srgbClr val="3F1900"/>
+              </a:solidFill>
+            </a:endParaRPr>
+          </a:p>
+        </p:txBody>
+      </p:sp>
+      <p:sp>
+        <p:nvSpPr>
+          <p:cNvPr id="4" name="Content Placeholder 3"/>
+          <p:cNvSpPr txBox="1">
+            <a:spLocks/>
+          </p:cNvSpPr>
+          <p:nvPr/>
+        </p:nvSpPr>
+        <p:spPr>
+          <a:xfrm>
+            <a:off x="1331640" y="1196753"/>
+            <a:ext cx="7488832" cy="5137780"/>
+          </a:xfrm>
+          <a:prstGeom prst="rect">
+            <a:avLst/>
+          </a:prstGeom>
+        </p:spPr>
+        <p:txBody>
+          <a:bodyPr>
+            <a:normAutofit/>
+          </a:bodyPr>
+          <a:lstStyle>
+            <a:lvl1pPr marL="342900" indent="-342900" algn="l" defTabSz="914400" rtl="0" eaLnBrk="1" latinLnBrk="0" hangingPunct="1">
+              <a:spcBef>
+                <a:spcPct val="20000"/>
+              </a:spcBef>
+              <a:buFont typeface="Arial" panose="020B0604020202020204" pitchFamily="34" charset="0"/>
+              <a:buChar char="•"/>
+              <a:defRPr sz="3200" kern="1200">
+                <a:solidFill>
+                  <a:schemeClr val="tx1"/>
+                </a:solidFill>
+                <a:latin typeface="+mn-lt"/>
+                <a:ea typeface="+mn-ea"/>
+                <a:cs typeface="+mn-cs"/>
+              </a:defRPr>
+            </a:lvl1pPr>
+            <a:lvl2pPr marL="742950" indent="-285750" algn="l" defTabSz="914400" rtl="0" eaLnBrk="1" latinLnBrk="0" hangingPunct="1">
+              <a:spcBef>
+                <a:spcPct val="20000"/>
+              </a:spcBef>
+              <a:buFont typeface="Arial" panose="020B0604020202020204" pitchFamily="34" charset="0"/>
+              <a:buChar char="–"/>
+              <a:defRPr sz="2800" kern="1200">
+                <a:solidFill>
+                  <a:schemeClr val="tx1"/>
+                </a:solidFill>
+                <a:latin typeface="+mn-lt"/>
+                <a:ea typeface="+mn-ea"/>
+                <a:cs typeface="+mn-cs"/>
+              </a:defRPr>
+            </a:lvl2pPr>
+            <a:lvl3pPr marL="1143000" indent="-228600" algn="l" defTabSz="914400" rtl="0" eaLnBrk="1" latinLnBrk="0" hangingPunct="1">
+              <a:spcBef>
+                <a:spcPct val="20000"/>
+              </a:spcBef>
+              <a:buFont typeface="Arial" panose="020B0604020202020204" pitchFamily="34" charset="0"/>
+              <a:buChar char="•"/>
+              <a:defRPr sz="2400" kern="1200">
+                <a:solidFill>
+                  <a:schemeClr val="tx1"/>
+                </a:solidFill>
+                <a:latin typeface="+mn-lt"/>
+                <a:ea typeface="+mn-ea"/>
+                <a:cs typeface="+mn-cs"/>
+              </a:defRPr>
+            </a:lvl3pPr>
+            <a:lvl4pPr marL="1600200" indent="-228600" algn="l" defTabSz="914400" rtl="0" eaLnBrk="1" latinLnBrk="0" hangingPunct="1">
+              <a:spcBef>
+                <a:spcPct val="20000"/>
+              </a:spcBef>
+              <a:buFont typeface="Arial" panose="020B0604020202020204" pitchFamily="34" charset="0"/>
+              <a:buChar char="–"/>
+              <a:defRPr sz="2000" kern="1200">
+                <a:solidFill>
+                  <a:schemeClr val="tx1"/>
+                </a:solidFill>
+                <a:latin typeface="+mn-lt"/>
+                <a:ea typeface="+mn-ea"/>
+                <a:cs typeface="+mn-cs"/>
+              </a:defRPr>
+            </a:lvl4pPr>
+            <a:lvl5pPr marL="2057400" indent="-228600" algn="l" defTabSz="914400" rtl="0" eaLnBrk="1" latinLnBrk="0" hangingPunct="1">
+              <a:spcBef>
+                <a:spcPct val="20000"/>
+              </a:spcBef>
+              <a:buFont typeface="Arial" panose="020B0604020202020204" pitchFamily="34" charset="0"/>
+              <a:buChar char="»"/>
+              <a:defRPr sz="2000" kern="1200">
+                <a:solidFill>
+                  <a:schemeClr val="tx1"/>
+                </a:solidFill>
+                <a:latin typeface="+mn-lt"/>
+                <a:ea typeface="+mn-ea"/>
+                <a:cs typeface="+mn-cs"/>
+              </a:defRPr>
+            </a:lvl5pPr>
+            <a:lvl6pPr marL="2514600" indent="-228600" algn="l" defTabSz="914400" rtl="0" eaLnBrk="1" latinLnBrk="0" hangingPunct="1">
+              <a:spcBef>
+                <a:spcPct val="20000"/>
+              </a:spcBef>
+              <a:buFont typeface="Arial" panose="020B0604020202020204" pitchFamily="34" charset="0"/>
+              <a:buChar char="•"/>
+              <a:defRPr sz="2000" kern="1200">
+                <a:solidFill>
+                  <a:schemeClr val="tx1"/>
+                </a:solidFill>
+                <a:latin typeface="+mn-lt"/>
+                <a:ea typeface="+mn-ea"/>
+                <a:cs typeface="+mn-cs"/>
+              </a:defRPr>
+            </a:lvl6pPr>
+            <a:lvl7pPr marL="2971800" indent="-228600" algn="l" defTabSz="914400" rtl="0" eaLnBrk="1" latinLnBrk="0" hangingPunct="1">
+              <a:spcBef>
+                <a:spcPct val="20000"/>
+              </a:spcBef>
+              <a:buFont typeface="Arial" panose="020B0604020202020204" pitchFamily="34" charset="0"/>
+              <a:buChar char="•"/>
+              <a:defRPr sz="2000" kern="1200">
+                <a:solidFill>
+                  <a:schemeClr val="tx1"/>
+                </a:solidFill>
+                <a:latin typeface="+mn-lt"/>
+                <a:ea typeface="+mn-ea"/>
+                <a:cs typeface="+mn-cs"/>
+              </a:defRPr>
+            </a:lvl7pPr>
+            <a:lvl8pPr marL="3429000" indent="-228600" algn="l" defTabSz="914400" rtl="0" eaLnBrk="1" latinLnBrk="0" hangingPunct="1">
+              <a:spcBef>
+                <a:spcPct val="20000"/>
+              </a:spcBef>
+              <a:buFont typeface="Arial" panose="020B0604020202020204" pitchFamily="34" charset="0"/>
+              <a:buChar char="•"/>
+              <a:defRPr sz="2000" kern="1200">
+                <a:solidFill>
+                  <a:schemeClr val="tx1"/>
+                </a:solidFill>
+                <a:latin typeface="+mn-lt"/>
+                <a:ea typeface="+mn-ea"/>
+                <a:cs typeface="+mn-cs"/>
+              </a:defRPr>
+            </a:lvl8pPr>
+            <a:lvl9pPr marL="3886200" indent="-228600" algn="l" defTabSz="914400" rtl="0" eaLnBrk="1" latinLnBrk="0" hangingPunct="1">
+              <a:spcBef>
+                <a:spcPct val="20000"/>
+              </a:spcBef>
+              <a:buFont typeface="Arial" panose="020B0604020202020204" pitchFamily="34" charset="0"/>
+              <a:buChar char="•"/>
+              <a:defRPr sz="2000" kern="1200">
+                <a:solidFill>
+                  <a:schemeClr val="tx1"/>
+                </a:solidFill>
+                <a:latin typeface="+mn-lt"/>
+                <a:ea typeface="+mn-ea"/>
+                <a:cs typeface="+mn-cs"/>
+              </a:defRPr>
+            </a:lvl9pPr>
+          </a:lstStyle>
+          <a:p>
+            <a:pPr marL="0" indent="0" algn="just">
+              <a:buFont typeface="Arial" panose="020B0604020202020204" pitchFamily="34" charset="0"/>
+              <a:buNone/>
+            </a:pPr>
+            <a:endParaRPr lang="en-US" sz="2000" i="1"/>
+          </a:p>
+        </p:txBody>
+      </p:sp>
+      <p:sp>
+        <p:nvSpPr>
+          <p:cNvPr id="10" name="Rectangle 9"/>
+          <p:cNvSpPr/>
+          <p:nvPr/>
+        </p:nvSpPr>
+        <p:spPr>
+          <a:xfrm>
+            <a:off x="1187624" y="1095133"/>
+            <a:ext cx="7776864" cy="646331"/>
+          </a:xfrm>
+          <a:prstGeom prst="rect">
+            <a:avLst/>
+          </a:prstGeom>
+        </p:spPr>
+        <p:txBody>
+          <a:bodyPr wrap="square">
+            <a:spAutoFit/>
+          </a:bodyPr>
+          <a:lstStyle/>
+          <a:p>
+            <a:pPr>
+              <a:buFont typeface="Arial" panose="020B0604020202020204" pitchFamily="34" charset="0"/>
+              <a:buChar char="•"/>
+            </a:pPr>
+            <a:r>
+              <a:rPr lang="es-ES" sz="1200" b="0" i="0" dirty="0">
+                <a:solidFill>
+                  <a:srgbClr val="222222"/>
+                </a:solidFill>
+                <a:effectLst/>
+                <a:latin typeface="Segoe UI" panose="020B0502040204020203" pitchFamily="34" charset="0"/>
+              </a:rPr>
+              <a:t> </a:t>
+            </a:r>
+            <a:r>
+              <a:rPr lang="es-ES" sz="1200" dirty="0">
+                <a:solidFill>
+                  <a:srgbClr val="222222"/>
+                </a:solidFill>
+                <a:latin typeface="Segoe UI" panose="020B0502040204020203" pitchFamily="34" charset="0"/>
+              </a:rPr>
+              <a:t>Se termino</a:t>
+            </a:r>
+            <a:r>
+              <a:rPr lang="es-ES" sz="1200" b="0" i="0" dirty="0">
+                <a:solidFill>
+                  <a:srgbClr val="222222"/>
+                </a:solidFill>
+                <a:effectLst/>
+                <a:latin typeface="Segoe UI" panose="020B0502040204020203" pitchFamily="34" charset="0"/>
+              </a:rPr>
+              <a:t> de migrar y rediseñar los reportes de PPM’S de Certificación</a:t>
+            </a:r>
+            <a:r>
+              <a:rPr lang="es-ES" sz="1200" dirty="0">
+                <a:solidFill>
+                  <a:srgbClr val="222222"/>
+                </a:solidFill>
+                <a:latin typeface="Segoe UI" panose="020B0502040204020203" pitchFamily="34" charset="0"/>
+              </a:rPr>
+              <a:t> de formato Excel a PDF y se envió a calidad para su revisión.</a:t>
+            </a:r>
+          </a:p>
+          <a:p>
+            <a:pPr>
+              <a:buFont typeface="Arial" panose="020B0604020202020204" pitchFamily="34" charset="0"/>
+              <a:buChar char="•"/>
+            </a:pPr>
+            <a:r>
+              <a:rPr lang="es-ES" sz="1200" b="0" i="0" dirty="0">
+                <a:solidFill>
+                  <a:srgbClr val="222222"/>
+                </a:solidFill>
+                <a:effectLst/>
+                <a:latin typeface="Segoe UI" panose="020B0502040204020203" pitchFamily="34" charset="0"/>
+              </a:rPr>
+              <a:t> Se empezó con el rediseño y guardado completo de la información en la Pantalla Certification Report. </a:t>
+            </a:r>
+          </a:p>
+        </p:txBody>
+      </p:sp>
+      <p:pic>
+        <p:nvPicPr>
+          <p:cNvPr id="5" name="Imagen 4" descr="Interfaz de usuario gráfica, Aplicación, Tabla, Excel&#10;&#10;Descripción generada automáticamente">
+            <a:extLst>
+              <a:ext uri="{FF2B5EF4-FFF2-40B4-BE49-F238E27FC236}">
+                <a16:creationId xmlns:a16="http://schemas.microsoft.com/office/drawing/2014/main" id="{FBEEE617-D98D-4A42-8651-F6B06535573D}"/>
+              </a:ext>
+            </a:extLst>
+          </p:cNvPr>
+          <p:cNvPicPr>
+            <a:picLocks noChangeAspect="1"/>
+          </p:cNvPicPr>
+          <p:nvPr/>
+        </p:nvPicPr>
+        <p:blipFill>
+          <a:blip r:embed="rId2">
+            <a:extLst>
+              <a:ext uri="{28A0092B-C50C-407E-A947-70E740481C1C}">
+                <a14:useLocalDpi xmlns:a14="http://schemas.microsoft.com/office/drawing/2010/main" val="0"/>
+              </a:ext>
+            </a:extLst>
+          </a:blip>
+          <a:stretch>
+            <a:fillRect/>
+          </a:stretch>
+        </p:blipFill>
+        <p:spPr>
+          <a:xfrm>
+            <a:off x="1187624" y="1741464"/>
+            <a:ext cx="7920880" cy="5071912"/>
+          </a:xfrm>
+          <a:prstGeom prst="rect">
+            <a:avLst/>
+          </a:prstGeom>
+        </p:spPr>
+      </p:pic>
+    </p:spTree>
+    <p:extLst>
+      <p:ext uri="{BB962C8B-B14F-4D97-AF65-F5344CB8AC3E}">
+        <p14:creationId xmlns:p14="http://schemas.microsoft.com/office/powerpoint/2010/main" val="3323146812"/>
+      </p:ext>
+    </p:extLst>
+  </p:cSld>
+  <p:clrMapOvr>
+    <a:masterClrMapping/>
+  </p:clrMapOvr>
+</p:sld>
+</file>
+
+<file path=ppt/slides/slide3.xml><?xml version="1.0" encoding="utf-8"?>
+<p:sld xmlns:a="http://schemas.openxmlformats.org/drawingml/2006/main" xmlns:r="http://schemas.openxmlformats.org/officeDocument/2006/relationships" xmlns:p="http://schemas.openxmlformats.org/presentationml/2006/main">
+  <p:cSld>
+    <p:spTree>
+      <p:nvGrpSpPr>
+        <p:cNvPr id="1" name=""/>
+        <p:cNvGrpSpPr/>
+        <p:nvPr/>
+      </p:nvGrpSpPr>
+      <p:grpSpPr>
+        <a:xfrm>
+          <a:off x="0" y="0"/>
+          <a:ext cx="0" cy="0"/>
+          <a:chOff x="0" y="0"/>
+          <a:chExt cx="0" cy="0"/>
+        </a:xfrm>
+      </p:grpSpPr>
+      <p:sp>
+        <p:nvSpPr>
+          <p:cNvPr id="5" name="Title 1"/>
+          <p:cNvSpPr txBox="1">
+            <a:spLocks/>
+          </p:cNvSpPr>
+          <p:nvPr/>
+        </p:nvSpPr>
+        <p:spPr>
+          <a:xfrm>
+            <a:off x="1187624" y="2564904"/>
+            <a:ext cx="7772400" cy="1470025"/>
+          </a:xfrm>
+          <a:prstGeom prst="rect">
+            <a:avLst/>
+          </a:prstGeom>
+        </p:spPr>
+        <p:txBody>
+          <a:bodyPr vert="horz" lIns="91440" tIns="45720" rIns="91440" bIns="45720" rtlCol="0" anchor="ctr">
+            <a:normAutofit/>
+          </a:bodyPr>
+          <a:lstStyle>
+            <a:lvl1pPr algn="ctr" defTabSz="914400" rtl="0" eaLnBrk="1" latinLnBrk="0" hangingPunct="1">
+              <a:spcBef>
+                <a:spcPct val="0"/>
+              </a:spcBef>
+              <a:buNone/>
+              <a:defRPr sz="4400" kern="1200">
+                <a:solidFill>
+                  <a:schemeClr val="tx1"/>
+                </a:solidFill>
+                <a:latin typeface="+mj-lt"/>
+                <a:ea typeface="+mj-ea"/>
+                <a:cs typeface="+mj-cs"/>
+              </a:defRPr>
+            </a:lvl1pPr>
+          </a:lstStyle>
+          <a:p>
+            <a:r>
+              <a:rPr lang="es-MX" b="1" dirty="0">
+                <a:latin typeface="Century Gothic" panose="020B0502020202020204" pitchFamily="34" charset="0"/>
+              </a:rPr>
+              <a:t>20/09/2021 – 24/09/2021</a:t>
+            </a:r>
+            <a:endParaRPr lang="es-MX" dirty="0">
+              <a:latin typeface="Century Gothic" panose="020B0502020202020204" pitchFamily="34" charset="0"/>
+            </a:endParaRPr>
+          </a:p>
+        </p:txBody>
+      </p:sp>
+    </p:spTree>
+    <p:extLst>
+      <p:ext uri="{BB962C8B-B14F-4D97-AF65-F5344CB8AC3E}">
+        <p14:creationId xmlns:p14="http://schemas.microsoft.com/office/powerpoint/2010/main" val="1994845445"/>
+      </p:ext>
+    </p:extLst>
+  </p:cSld>
+  <p:clrMapOvr>
+    <a:masterClrMapping/>
+  </p:clrMapOvr>
+</p:sld>
+</file>
+
+<file path=ppt/slides/slide4.xml><?xml version="1.0" encoding="utf-8"?>
 <p:sld xmlns:a="http://schemas.openxmlformats.org/drawingml/2006/main" xmlns:r="http://schemas.openxmlformats.org/officeDocument/2006/relationships" xmlns:p="http://schemas.openxmlformats.org/presentationml/2006/main">
   <p:cSld>
     <p:spTree>

</xml_diff>

<commit_message>
se eliminaron archivos que no se ocupaban
</commit_message>
<xml_diff>
--- a/60_PPM'S_CERTIFICACION/Docs/IT_DEV_PPMS_CERTIFICACION_REPORT.pptx
+++ b/60_PPM'S_CERTIFICACION/Docs/IT_DEV_PPMS_CERTIFICACION_REPORT.pptx
@@ -5,13 +5,17 @@
     <p:sldMasterId id="2147483648" r:id="rId1"/>
   </p:sldMasterIdLst>
   <p:notesMasterIdLst>
-    <p:notesMasterId r:id="rId6"/>
+    <p:notesMasterId r:id="rId10"/>
   </p:notesMasterIdLst>
   <p:sldIdLst>
     <p:sldId id="397" r:id="rId2"/>
     <p:sldId id="420" r:id="rId3"/>
-    <p:sldId id="419" r:id="rId4"/>
-    <p:sldId id="418" r:id="rId5"/>
+    <p:sldId id="423" r:id="rId4"/>
+    <p:sldId id="424" r:id="rId5"/>
+    <p:sldId id="421" r:id="rId6"/>
+    <p:sldId id="422" r:id="rId7"/>
+    <p:sldId id="419" r:id="rId8"/>
+    <p:sldId id="418" r:id="rId9"/>
   </p:sldIdLst>
   <p:sldSz cx="9144000" cy="6858000" type="screen4x3"/>
   <p:notesSz cx="6858000" cy="9144000"/>
@@ -211,7 +215,7 @@
           <a:p>
             <a:fld id="{A17B1792-3256-4E77-8442-3E205CD69EF5}" type="datetimeFigureOut">
               <a:rPr lang="en-US" smtClean="0"/>
-              <a:t>10/11/2021</a:t>
+              <a:t>11/15/2021</a:t>
             </a:fld>
             <a:endParaRPr lang="en-US"/>
           </a:p>
@@ -657,7 +661,7 @@
           <a:p>
             <a:fld id="{07558649-2619-44F9-8F30-2D6466E57529}" type="datetimeFigureOut">
               <a:rPr lang="en-US" smtClean="0"/>
-              <a:t>10/11/2021</a:t>
+              <a:t>11/15/2021</a:t>
             </a:fld>
             <a:endParaRPr lang="en-US"/>
           </a:p>
@@ -825,7 +829,7 @@
           <a:p>
             <a:fld id="{07558649-2619-44F9-8F30-2D6466E57529}" type="datetimeFigureOut">
               <a:rPr lang="en-US" smtClean="0"/>
-              <a:t>10/11/2021</a:t>
+              <a:t>11/15/2021</a:t>
             </a:fld>
             <a:endParaRPr lang="en-US"/>
           </a:p>
@@ -1003,7 +1007,7 @@
           <a:p>
             <a:fld id="{07558649-2619-44F9-8F30-2D6466E57529}" type="datetimeFigureOut">
               <a:rPr lang="en-US" smtClean="0"/>
-              <a:t>10/11/2021</a:t>
+              <a:t>11/15/2021</a:t>
             </a:fld>
             <a:endParaRPr lang="en-US"/>
           </a:p>
@@ -1171,7 +1175,7 @@
           <a:p>
             <a:fld id="{07558649-2619-44F9-8F30-2D6466E57529}" type="datetimeFigureOut">
               <a:rPr lang="en-US" smtClean="0"/>
-              <a:t>10/11/2021</a:t>
+              <a:t>11/15/2021</a:t>
             </a:fld>
             <a:endParaRPr lang="en-US"/>
           </a:p>
@@ -1416,7 +1420,7 @@
           <a:p>
             <a:fld id="{07558649-2619-44F9-8F30-2D6466E57529}" type="datetimeFigureOut">
               <a:rPr lang="en-US" smtClean="0"/>
-              <a:t>10/11/2021</a:t>
+              <a:t>11/15/2021</a:t>
             </a:fld>
             <a:endParaRPr lang="en-US"/>
           </a:p>
@@ -1701,7 +1705,7 @@
           <a:p>
             <a:fld id="{07558649-2619-44F9-8F30-2D6466E57529}" type="datetimeFigureOut">
               <a:rPr lang="en-US" smtClean="0"/>
-              <a:t>10/11/2021</a:t>
+              <a:t>11/15/2021</a:t>
             </a:fld>
             <a:endParaRPr lang="en-US"/>
           </a:p>
@@ -2120,7 +2124,7 @@
           <a:p>
             <a:fld id="{07558649-2619-44F9-8F30-2D6466E57529}" type="datetimeFigureOut">
               <a:rPr lang="en-US" smtClean="0"/>
-              <a:t>10/11/2021</a:t>
+              <a:t>11/15/2021</a:t>
             </a:fld>
             <a:endParaRPr lang="en-US"/>
           </a:p>
@@ -2237,7 +2241,7 @@
           <a:p>
             <a:fld id="{07558649-2619-44F9-8F30-2D6466E57529}" type="datetimeFigureOut">
               <a:rPr lang="en-US" smtClean="0"/>
-              <a:t>10/11/2021</a:t>
+              <a:t>11/15/2021</a:t>
             </a:fld>
             <a:endParaRPr lang="en-US"/>
           </a:p>
@@ -2332,7 +2336,7 @@
           <a:p>
             <a:fld id="{07558649-2619-44F9-8F30-2D6466E57529}" type="datetimeFigureOut">
               <a:rPr lang="en-US" smtClean="0"/>
-              <a:t>10/11/2021</a:t>
+              <a:t>11/15/2021</a:t>
             </a:fld>
             <a:endParaRPr lang="en-US"/>
           </a:p>
@@ -2607,7 +2611,7 @@
           <a:p>
             <a:fld id="{07558649-2619-44F9-8F30-2D6466E57529}" type="datetimeFigureOut">
               <a:rPr lang="en-US" smtClean="0"/>
-              <a:t>10/11/2021</a:t>
+              <a:t>11/15/2021</a:t>
             </a:fld>
             <a:endParaRPr lang="en-US"/>
           </a:p>
@@ -2859,7 +2863,7 @@
           <a:p>
             <a:fld id="{07558649-2619-44F9-8F30-2D6466E57529}" type="datetimeFigureOut">
               <a:rPr lang="en-US" smtClean="0"/>
-              <a:t>10/11/2021</a:t>
+              <a:t>11/15/2021</a:t>
             </a:fld>
             <a:endParaRPr lang="en-US"/>
           </a:p>
@@ -3079,7 +3083,7 @@
           <a:p>
             <a:fld id="{07558649-2619-44F9-8F30-2D6466E57529}" type="datetimeFigureOut">
               <a:rPr lang="en-US" smtClean="0"/>
-              <a:t>10/11/2021</a:t>
+              <a:t>11/15/2021</a:t>
             </a:fld>
             <a:endParaRPr lang="en-US"/>
           </a:p>
@@ -3496,7 +3500,7 @@
               <a:rPr lang="es-MX" b="1" dirty="0">
                 <a:latin typeface="Century Gothic" panose="020B0502020202020204" pitchFamily="34" charset="0"/>
               </a:rPr>
-              <a:t>04/10/2021 – 08/10/2021</a:t>
+              <a:t>08/11/2021 – 12/11/2021</a:t>
             </a:r>
             <a:endParaRPr lang="es-MX" dirty="0">
               <a:latin typeface="Century Gothic" panose="020B0502020202020204" pitchFamily="34" charset="0"/>
@@ -3518,6 +3522,1157 @@
 </file>
 
 <file path=ppt/slides/slide2.xml><?xml version="1.0" encoding="utf-8"?>
+<p:sld xmlns:a="http://schemas.openxmlformats.org/drawingml/2006/main" xmlns:r="http://schemas.openxmlformats.org/officeDocument/2006/relationships" xmlns:p="http://schemas.openxmlformats.org/presentationml/2006/main">
+  <p:cSld>
+    <p:spTree>
+      <p:nvGrpSpPr>
+        <p:cNvPr id="1" name=""/>
+        <p:cNvGrpSpPr/>
+        <p:nvPr/>
+      </p:nvGrpSpPr>
+      <p:grpSpPr>
+        <a:xfrm>
+          <a:off x="0" y="0"/>
+          <a:ext cx="0" cy="0"/>
+          <a:chOff x="0" y="0"/>
+          <a:chExt cx="0" cy="0"/>
+        </a:xfrm>
+      </p:grpSpPr>
+      <p:sp>
+        <p:nvSpPr>
+          <p:cNvPr id="8" name="Title 1"/>
+          <p:cNvSpPr txBox="1">
+            <a:spLocks/>
+          </p:cNvSpPr>
+          <p:nvPr/>
+        </p:nvSpPr>
+        <p:spPr>
+          <a:xfrm>
+            <a:off x="1087408" y="274638"/>
+            <a:ext cx="7229008" cy="634082"/>
+          </a:xfrm>
+          <a:prstGeom prst="rect">
+            <a:avLst/>
+          </a:prstGeom>
+        </p:spPr>
+        <p:txBody>
+          <a:bodyPr/>
+          <a:lstStyle>
+            <a:lvl1pPr algn="ctr" defTabSz="914400" rtl="0" eaLnBrk="1" latinLnBrk="0" hangingPunct="1">
+              <a:spcBef>
+                <a:spcPct val="0"/>
+              </a:spcBef>
+              <a:buNone/>
+              <a:defRPr sz="4400" kern="1200">
+                <a:solidFill>
+                  <a:schemeClr val="tx1"/>
+                </a:solidFill>
+                <a:latin typeface="+mj-lt"/>
+                <a:ea typeface="+mj-ea"/>
+                <a:cs typeface="+mj-cs"/>
+              </a:defRPr>
+            </a:lvl1pPr>
+          </a:lstStyle>
+          <a:p>
+            <a:pPr algn="l"/>
+            <a:r>
+              <a:rPr lang="es-ES" sz="2000" dirty="0">
+                <a:solidFill>
+                  <a:srgbClr val="3F1900"/>
+                </a:solidFill>
+              </a:rPr>
+              <a:t>QC: Pantalla Certification Report.</a:t>
+            </a:r>
+            <a:endParaRPr lang="en-US" sz="2000" dirty="0">
+              <a:solidFill>
+                <a:srgbClr val="3F1900"/>
+              </a:solidFill>
+            </a:endParaRPr>
+          </a:p>
+        </p:txBody>
+      </p:sp>
+      <p:sp>
+        <p:nvSpPr>
+          <p:cNvPr id="4" name="Content Placeholder 3"/>
+          <p:cNvSpPr txBox="1">
+            <a:spLocks/>
+          </p:cNvSpPr>
+          <p:nvPr/>
+        </p:nvSpPr>
+        <p:spPr>
+          <a:xfrm>
+            <a:off x="1331640" y="1196753"/>
+            <a:ext cx="7488832" cy="5137780"/>
+          </a:xfrm>
+          <a:prstGeom prst="rect">
+            <a:avLst/>
+          </a:prstGeom>
+        </p:spPr>
+        <p:txBody>
+          <a:bodyPr>
+            <a:normAutofit/>
+          </a:bodyPr>
+          <a:lstStyle>
+            <a:lvl1pPr marL="342900" indent="-342900" algn="l" defTabSz="914400" rtl="0" eaLnBrk="1" latinLnBrk="0" hangingPunct="1">
+              <a:spcBef>
+                <a:spcPct val="20000"/>
+              </a:spcBef>
+              <a:buFont typeface="Arial" panose="020B0604020202020204" pitchFamily="34" charset="0"/>
+              <a:buChar char="•"/>
+              <a:defRPr sz="3200" kern="1200">
+                <a:solidFill>
+                  <a:schemeClr val="tx1"/>
+                </a:solidFill>
+                <a:latin typeface="+mn-lt"/>
+                <a:ea typeface="+mn-ea"/>
+                <a:cs typeface="+mn-cs"/>
+              </a:defRPr>
+            </a:lvl1pPr>
+            <a:lvl2pPr marL="742950" indent="-285750" algn="l" defTabSz="914400" rtl="0" eaLnBrk="1" latinLnBrk="0" hangingPunct="1">
+              <a:spcBef>
+                <a:spcPct val="20000"/>
+              </a:spcBef>
+              <a:buFont typeface="Arial" panose="020B0604020202020204" pitchFamily="34" charset="0"/>
+              <a:buChar char="–"/>
+              <a:defRPr sz="2800" kern="1200">
+                <a:solidFill>
+                  <a:schemeClr val="tx1"/>
+                </a:solidFill>
+                <a:latin typeface="+mn-lt"/>
+                <a:ea typeface="+mn-ea"/>
+                <a:cs typeface="+mn-cs"/>
+              </a:defRPr>
+            </a:lvl2pPr>
+            <a:lvl3pPr marL="1143000" indent="-228600" algn="l" defTabSz="914400" rtl="0" eaLnBrk="1" latinLnBrk="0" hangingPunct="1">
+              <a:spcBef>
+                <a:spcPct val="20000"/>
+              </a:spcBef>
+              <a:buFont typeface="Arial" panose="020B0604020202020204" pitchFamily="34" charset="0"/>
+              <a:buChar char="•"/>
+              <a:defRPr sz="2400" kern="1200">
+                <a:solidFill>
+                  <a:schemeClr val="tx1"/>
+                </a:solidFill>
+                <a:latin typeface="+mn-lt"/>
+                <a:ea typeface="+mn-ea"/>
+                <a:cs typeface="+mn-cs"/>
+              </a:defRPr>
+            </a:lvl3pPr>
+            <a:lvl4pPr marL="1600200" indent="-228600" algn="l" defTabSz="914400" rtl="0" eaLnBrk="1" latinLnBrk="0" hangingPunct="1">
+              <a:spcBef>
+                <a:spcPct val="20000"/>
+              </a:spcBef>
+              <a:buFont typeface="Arial" panose="020B0604020202020204" pitchFamily="34" charset="0"/>
+              <a:buChar char="–"/>
+              <a:defRPr sz="2000" kern="1200">
+                <a:solidFill>
+                  <a:schemeClr val="tx1"/>
+                </a:solidFill>
+                <a:latin typeface="+mn-lt"/>
+                <a:ea typeface="+mn-ea"/>
+                <a:cs typeface="+mn-cs"/>
+              </a:defRPr>
+            </a:lvl4pPr>
+            <a:lvl5pPr marL="2057400" indent="-228600" algn="l" defTabSz="914400" rtl="0" eaLnBrk="1" latinLnBrk="0" hangingPunct="1">
+              <a:spcBef>
+                <a:spcPct val="20000"/>
+              </a:spcBef>
+              <a:buFont typeface="Arial" panose="020B0604020202020204" pitchFamily="34" charset="0"/>
+              <a:buChar char="»"/>
+              <a:defRPr sz="2000" kern="1200">
+                <a:solidFill>
+                  <a:schemeClr val="tx1"/>
+                </a:solidFill>
+                <a:latin typeface="+mn-lt"/>
+                <a:ea typeface="+mn-ea"/>
+                <a:cs typeface="+mn-cs"/>
+              </a:defRPr>
+            </a:lvl5pPr>
+            <a:lvl6pPr marL="2514600" indent="-228600" algn="l" defTabSz="914400" rtl="0" eaLnBrk="1" latinLnBrk="0" hangingPunct="1">
+              <a:spcBef>
+                <a:spcPct val="20000"/>
+              </a:spcBef>
+              <a:buFont typeface="Arial" panose="020B0604020202020204" pitchFamily="34" charset="0"/>
+              <a:buChar char="•"/>
+              <a:defRPr sz="2000" kern="1200">
+                <a:solidFill>
+                  <a:schemeClr val="tx1"/>
+                </a:solidFill>
+                <a:latin typeface="+mn-lt"/>
+                <a:ea typeface="+mn-ea"/>
+                <a:cs typeface="+mn-cs"/>
+              </a:defRPr>
+            </a:lvl6pPr>
+            <a:lvl7pPr marL="2971800" indent="-228600" algn="l" defTabSz="914400" rtl="0" eaLnBrk="1" latinLnBrk="0" hangingPunct="1">
+              <a:spcBef>
+                <a:spcPct val="20000"/>
+              </a:spcBef>
+              <a:buFont typeface="Arial" panose="020B0604020202020204" pitchFamily="34" charset="0"/>
+              <a:buChar char="•"/>
+              <a:defRPr sz="2000" kern="1200">
+                <a:solidFill>
+                  <a:schemeClr val="tx1"/>
+                </a:solidFill>
+                <a:latin typeface="+mn-lt"/>
+                <a:ea typeface="+mn-ea"/>
+                <a:cs typeface="+mn-cs"/>
+              </a:defRPr>
+            </a:lvl7pPr>
+            <a:lvl8pPr marL="3429000" indent="-228600" algn="l" defTabSz="914400" rtl="0" eaLnBrk="1" latinLnBrk="0" hangingPunct="1">
+              <a:spcBef>
+                <a:spcPct val="20000"/>
+              </a:spcBef>
+              <a:buFont typeface="Arial" panose="020B0604020202020204" pitchFamily="34" charset="0"/>
+              <a:buChar char="•"/>
+              <a:defRPr sz="2000" kern="1200">
+                <a:solidFill>
+                  <a:schemeClr val="tx1"/>
+                </a:solidFill>
+                <a:latin typeface="+mn-lt"/>
+                <a:ea typeface="+mn-ea"/>
+                <a:cs typeface="+mn-cs"/>
+              </a:defRPr>
+            </a:lvl8pPr>
+            <a:lvl9pPr marL="3886200" indent="-228600" algn="l" defTabSz="914400" rtl="0" eaLnBrk="1" latinLnBrk="0" hangingPunct="1">
+              <a:spcBef>
+                <a:spcPct val="20000"/>
+              </a:spcBef>
+              <a:buFont typeface="Arial" panose="020B0604020202020204" pitchFamily="34" charset="0"/>
+              <a:buChar char="•"/>
+              <a:defRPr sz="2000" kern="1200">
+                <a:solidFill>
+                  <a:schemeClr val="tx1"/>
+                </a:solidFill>
+                <a:latin typeface="+mn-lt"/>
+                <a:ea typeface="+mn-ea"/>
+                <a:cs typeface="+mn-cs"/>
+              </a:defRPr>
+            </a:lvl9pPr>
+          </a:lstStyle>
+          <a:p>
+            <a:pPr marL="0" indent="0" algn="just">
+              <a:buFont typeface="Arial" panose="020B0604020202020204" pitchFamily="34" charset="0"/>
+              <a:buNone/>
+            </a:pPr>
+            <a:endParaRPr lang="en-US" sz="2000" i="1"/>
+          </a:p>
+        </p:txBody>
+      </p:sp>
+      <p:sp>
+        <p:nvSpPr>
+          <p:cNvPr id="10" name="Rectangle 9"/>
+          <p:cNvSpPr/>
+          <p:nvPr/>
+        </p:nvSpPr>
+        <p:spPr>
+          <a:xfrm>
+            <a:off x="1187624" y="1095133"/>
+            <a:ext cx="7776864" cy="276999"/>
+          </a:xfrm>
+          <a:prstGeom prst="rect">
+            <a:avLst/>
+          </a:prstGeom>
+        </p:spPr>
+        <p:txBody>
+          <a:bodyPr wrap="square">
+            <a:spAutoFit/>
+          </a:bodyPr>
+          <a:lstStyle/>
+          <a:p>
+            <a:pPr>
+              <a:buFont typeface="Arial" panose="020B0604020202020204" pitchFamily="34" charset="0"/>
+              <a:buChar char="•"/>
+            </a:pPr>
+            <a:r>
+              <a:rPr lang="es-ES" sz="1200" b="0" i="0" dirty="0">
+                <a:solidFill>
+                  <a:srgbClr val="222222"/>
+                </a:solidFill>
+                <a:effectLst/>
+                <a:latin typeface="Segoe UI" panose="020B0502040204020203" pitchFamily="34" charset="0"/>
+              </a:rPr>
+              <a:t> </a:t>
+            </a:r>
+            <a:r>
+              <a:rPr lang="es-ES" sz="1200" dirty="0">
+                <a:solidFill>
+                  <a:srgbClr val="222222"/>
+                </a:solidFill>
+                <a:latin typeface="Segoe UI" panose="020B0502040204020203" pitchFamily="34" charset="0"/>
+              </a:rPr>
+              <a:t>Se agrego al Reporte de Certificación Acumulado del mes, </a:t>
+            </a:r>
+            <a:r>
+              <a:rPr lang="es-ES" sz="1200" b="1" dirty="0">
+                <a:solidFill>
+                  <a:srgbClr val="222222"/>
+                </a:solidFill>
+                <a:latin typeface="Segoe UI" panose="020B0502040204020203" pitchFamily="34" charset="0"/>
+              </a:rPr>
+              <a:t>Grafica de los defectos críticos.</a:t>
+            </a:r>
+            <a:endParaRPr lang="es-ES" sz="1200" b="0" i="0" dirty="0">
+              <a:solidFill>
+                <a:srgbClr val="222222"/>
+              </a:solidFill>
+              <a:effectLst/>
+              <a:latin typeface="Segoe UI" panose="020B0502040204020203" pitchFamily="34" charset="0"/>
+            </a:endParaRPr>
+          </a:p>
+        </p:txBody>
+      </p:sp>
+      <p:pic>
+        <p:nvPicPr>
+          <p:cNvPr id="3" name="Imagen 2">
+            <a:extLst>
+              <a:ext uri="{FF2B5EF4-FFF2-40B4-BE49-F238E27FC236}">
+                <a16:creationId xmlns:a16="http://schemas.microsoft.com/office/drawing/2014/main" id="{501D7ED6-A8FE-4E6B-A674-783D21B57D35}"/>
+              </a:ext>
+            </a:extLst>
+          </p:cNvPr>
+          <p:cNvPicPr>
+            <a:picLocks noChangeAspect="1"/>
+          </p:cNvPicPr>
+          <p:nvPr/>
+        </p:nvPicPr>
+        <p:blipFill>
+          <a:blip r:embed="rId2"/>
+          <a:stretch>
+            <a:fillRect/>
+          </a:stretch>
+        </p:blipFill>
+        <p:spPr>
+          <a:xfrm>
+            <a:off x="1140903" y="1484784"/>
+            <a:ext cx="7967601" cy="3168352"/>
+          </a:xfrm>
+          <a:prstGeom prst="rect">
+            <a:avLst/>
+          </a:prstGeom>
+        </p:spPr>
+      </p:pic>
+    </p:spTree>
+    <p:extLst>
+      <p:ext uri="{BB962C8B-B14F-4D97-AF65-F5344CB8AC3E}">
+        <p14:creationId xmlns:p14="http://schemas.microsoft.com/office/powerpoint/2010/main" val="3323146812"/>
+      </p:ext>
+    </p:extLst>
+  </p:cSld>
+  <p:clrMapOvr>
+    <a:masterClrMapping/>
+  </p:clrMapOvr>
+</p:sld>
+</file>
+
+<file path=ppt/slides/slide3.xml><?xml version="1.0" encoding="utf-8"?>
+<p:sld xmlns:a="http://schemas.openxmlformats.org/drawingml/2006/main" xmlns:r="http://schemas.openxmlformats.org/officeDocument/2006/relationships" xmlns:p="http://schemas.openxmlformats.org/presentationml/2006/main">
+  <p:cSld>
+    <p:spTree>
+      <p:nvGrpSpPr>
+        <p:cNvPr id="1" name=""/>
+        <p:cNvGrpSpPr/>
+        <p:nvPr/>
+      </p:nvGrpSpPr>
+      <p:grpSpPr>
+        <a:xfrm>
+          <a:off x="0" y="0"/>
+          <a:ext cx="0" cy="0"/>
+          <a:chOff x="0" y="0"/>
+          <a:chExt cx="0" cy="0"/>
+        </a:xfrm>
+      </p:grpSpPr>
+      <p:sp>
+        <p:nvSpPr>
+          <p:cNvPr id="8" name="Title 1"/>
+          <p:cNvSpPr txBox="1">
+            <a:spLocks/>
+          </p:cNvSpPr>
+          <p:nvPr/>
+        </p:nvSpPr>
+        <p:spPr>
+          <a:xfrm>
+            <a:off x="1087408" y="274638"/>
+            <a:ext cx="7229008" cy="634082"/>
+          </a:xfrm>
+          <a:prstGeom prst="rect">
+            <a:avLst/>
+          </a:prstGeom>
+        </p:spPr>
+        <p:txBody>
+          <a:bodyPr/>
+          <a:lstStyle>
+            <a:lvl1pPr algn="ctr" defTabSz="914400" rtl="0" eaLnBrk="1" latinLnBrk="0" hangingPunct="1">
+              <a:spcBef>
+                <a:spcPct val="0"/>
+              </a:spcBef>
+              <a:buNone/>
+              <a:defRPr sz="4400" kern="1200">
+                <a:solidFill>
+                  <a:schemeClr val="tx1"/>
+                </a:solidFill>
+                <a:latin typeface="+mj-lt"/>
+                <a:ea typeface="+mj-ea"/>
+                <a:cs typeface="+mj-cs"/>
+              </a:defRPr>
+            </a:lvl1pPr>
+          </a:lstStyle>
+          <a:p>
+            <a:pPr algn="l"/>
+            <a:r>
+              <a:rPr lang="es-ES" sz="2000" dirty="0">
+                <a:solidFill>
+                  <a:srgbClr val="3F1900"/>
+                </a:solidFill>
+              </a:rPr>
+              <a:t>QC: Pantalla Certification Report.</a:t>
+            </a:r>
+            <a:endParaRPr lang="en-US" sz="2000" dirty="0">
+              <a:solidFill>
+                <a:srgbClr val="3F1900"/>
+              </a:solidFill>
+            </a:endParaRPr>
+          </a:p>
+        </p:txBody>
+      </p:sp>
+      <p:sp>
+        <p:nvSpPr>
+          <p:cNvPr id="4" name="Content Placeholder 3"/>
+          <p:cNvSpPr txBox="1">
+            <a:spLocks/>
+          </p:cNvSpPr>
+          <p:nvPr/>
+        </p:nvSpPr>
+        <p:spPr>
+          <a:xfrm>
+            <a:off x="1331640" y="1196753"/>
+            <a:ext cx="7488832" cy="5137780"/>
+          </a:xfrm>
+          <a:prstGeom prst="rect">
+            <a:avLst/>
+          </a:prstGeom>
+        </p:spPr>
+        <p:txBody>
+          <a:bodyPr>
+            <a:normAutofit/>
+          </a:bodyPr>
+          <a:lstStyle>
+            <a:lvl1pPr marL="342900" indent="-342900" algn="l" defTabSz="914400" rtl="0" eaLnBrk="1" latinLnBrk="0" hangingPunct="1">
+              <a:spcBef>
+                <a:spcPct val="20000"/>
+              </a:spcBef>
+              <a:buFont typeface="Arial" panose="020B0604020202020204" pitchFamily="34" charset="0"/>
+              <a:buChar char="•"/>
+              <a:defRPr sz="3200" kern="1200">
+                <a:solidFill>
+                  <a:schemeClr val="tx1"/>
+                </a:solidFill>
+                <a:latin typeface="+mn-lt"/>
+                <a:ea typeface="+mn-ea"/>
+                <a:cs typeface="+mn-cs"/>
+              </a:defRPr>
+            </a:lvl1pPr>
+            <a:lvl2pPr marL="742950" indent="-285750" algn="l" defTabSz="914400" rtl="0" eaLnBrk="1" latinLnBrk="0" hangingPunct="1">
+              <a:spcBef>
+                <a:spcPct val="20000"/>
+              </a:spcBef>
+              <a:buFont typeface="Arial" panose="020B0604020202020204" pitchFamily="34" charset="0"/>
+              <a:buChar char="–"/>
+              <a:defRPr sz="2800" kern="1200">
+                <a:solidFill>
+                  <a:schemeClr val="tx1"/>
+                </a:solidFill>
+                <a:latin typeface="+mn-lt"/>
+                <a:ea typeface="+mn-ea"/>
+                <a:cs typeface="+mn-cs"/>
+              </a:defRPr>
+            </a:lvl2pPr>
+            <a:lvl3pPr marL="1143000" indent="-228600" algn="l" defTabSz="914400" rtl="0" eaLnBrk="1" latinLnBrk="0" hangingPunct="1">
+              <a:spcBef>
+                <a:spcPct val="20000"/>
+              </a:spcBef>
+              <a:buFont typeface="Arial" panose="020B0604020202020204" pitchFamily="34" charset="0"/>
+              <a:buChar char="•"/>
+              <a:defRPr sz="2400" kern="1200">
+                <a:solidFill>
+                  <a:schemeClr val="tx1"/>
+                </a:solidFill>
+                <a:latin typeface="+mn-lt"/>
+                <a:ea typeface="+mn-ea"/>
+                <a:cs typeface="+mn-cs"/>
+              </a:defRPr>
+            </a:lvl3pPr>
+            <a:lvl4pPr marL="1600200" indent="-228600" algn="l" defTabSz="914400" rtl="0" eaLnBrk="1" latinLnBrk="0" hangingPunct="1">
+              <a:spcBef>
+                <a:spcPct val="20000"/>
+              </a:spcBef>
+              <a:buFont typeface="Arial" panose="020B0604020202020204" pitchFamily="34" charset="0"/>
+              <a:buChar char="–"/>
+              <a:defRPr sz="2000" kern="1200">
+                <a:solidFill>
+                  <a:schemeClr val="tx1"/>
+                </a:solidFill>
+                <a:latin typeface="+mn-lt"/>
+                <a:ea typeface="+mn-ea"/>
+                <a:cs typeface="+mn-cs"/>
+              </a:defRPr>
+            </a:lvl4pPr>
+            <a:lvl5pPr marL="2057400" indent="-228600" algn="l" defTabSz="914400" rtl="0" eaLnBrk="1" latinLnBrk="0" hangingPunct="1">
+              <a:spcBef>
+                <a:spcPct val="20000"/>
+              </a:spcBef>
+              <a:buFont typeface="Arial" panose="020B0604020202020204" pitchFamily="34" charset="0"/>
+              <a:buChar char="»"/>
+              <a:defRPr sz="2000" kern="1200">
+                <a:solidFill>
+                  <a:schemeClr val="tx1"/>
+                </a:solidFill>
+                <a:latin typeface="+mn-lt"/>
+                <a:ea typeface="+mn-ea"/>
+                <a:cs typeface="+mn-cs"/>
+              </a:defRPr>
+            </a:lvl5pPr>
+            <a:lvl6pPr marL="2514600" indent="-228600" algn="l" defTabSz="914400" rtl="0" eaLnBrk="1" latinLnBrk="0" hangingPunct="1">
+              <a:spcBef>
+                <a:spcPct val="20000"/>
+              </a:spcBef>
+              <a:buFont typeface="Arial" panose="020B0604020202020204" pitchFamily="34" charset="0"/>
+              <a:buChar char="•"/>
+              <a:defRPr sz="2000" kern="1200">
+                <a:solidFill>
+                  <a:schemeClr val="tx1"/>
+                </a:solidFill>
+                <a:latin typeface="+mn-lt"/>
+                <a:ea typeface="+mn-ea"/>
+                <a:cs typeface="+mn-cs"/>
+              </a:defRPr>
+            </a:lvl6pPr>
+            <a:lvl7pPr marL="2971800" indent="-228600" algn="l" defTabSz="914400" rtl="0" eaLnBrk="1" latinLnBrk="0" hangingPunct="1">
+              <a:spcBef>
+                <a:spcPct val="20000"/>
+              </a:spcBef>
+              <a:buFont typeface="Arial" panose="020B0604020202020204" pitchFamily="34" charset="0"/>
+              <a:buChar char="•"/>
+              <a:defRPr sz="2000" kern="1200">
+                <a:solidFill>
+                  <a:schemeClr val="tx1"/>
+                </a:solidFill>
+                <a:latin typeface="+mn-lt"/>
+                <a:ea typeface="+mn-ea"/>
+                <a:cs typeface="+mn-cs"/>
+              </a:defRPr>
+            </a:lvl7pPr>
+            <a:lvl8pPr marL="3429000" indent="-228600" algn="l" defTabSz="914400" rtl="0" eaLnBrk="1" latinLnBrk="0" hangingPunct="1">
+              <a:spcBef>
+                <a:spcPct val="20000"/>
+              </a:spcBef>
+              <a:buFont typeface="Arial" panose="020B0604020202020204" pitchFamily="34" charset="0"/>
+              <a:buChar char="•"/>
+              <a:defRPr sz="2000" kern="1200">
+                <a:solidFill>
+                  <a:schemeClr val="tx1"/>
+                </a:solidFill>
+                <a:latin typeface="+mn-lt"/>
+                <a:ea typeface="+mn-ea"/>
+                <a:cs typeface="+mn-cs"/>
+              </a:defRPr>
+            </a:lvl8pPr>
+            <a:lvl9pPr marL="3886200" indent="-228600" algn="l" defTabSz="914400" rtl="0" eaLnBrk="1" latinLnBrk="0" hangingPunct="1">
+              <a:spcBef>
+                <a:spcPct val="20000"/>
+              </a:spcBef>
+              <a:buFont typeface="Arial" panose="020B0604020202020204" pitchFamily="34" charset="0"/>
+              <a:buChar char="•"/>
+              <a:defRPr sz="2000" kern="1200">
+                <a:solidFill>
+                  <a:schemeClr val="tx1"/>
+                </a:solidFill>
+                <a:latin typeface="+mn-lt"/>
+                <a:ea typeface="+mn-ea"/>
+                <a:cs typeface="+mn-cs"/>
+              </a:defRPr>
+            </a:lvl9pPr>
+          </a:lstStyle>
+          <a:p>
+            <a:pPr marL="0" indent="0" algn="just">
+              <a:buFont typeface="Arial" panose="020B0604020202020204" pitchFamily="34" charset="0"/>
+              <a:buNone/>
+            </a:pPr>
+            <a:endParaRPr lang="en-US" sz="2000" i="1"/>
+          </a:p>
+        </p:txBody>
+      </p:sp>
+      <p:sp>
+        <p:nvSpPr>
+          <p:cNvPr id="10" name="Rectangle 9"/>
+          <p:cNvSpPr/>
+          <p:nvPr/>
+        </p:nvSpPr>
+        <p:spPr>
+          <a:xfrm>
+            <a:off x="1187624" y="1095133"/>
+            <a:ext cx="7776864" cy="461665"/>
+          </a:xfrm>
+          <a:prstGeom prst="rect">
+            <a:avLst/>
+          </a:prstGeom>
+        </p:spPr>
+        <p:txBody>
+          <a:bodyPr wrap="square">
+            <a:spAutoFit/>
+          </a:bodyPr>
+          <a:lstStyle/>
+          <a:p>
+            <a:pPr>
+              <a:buFont typeface="Arial" panose="020B0604020202020204" pitchFamily="34" charset="0"/>
+              <a:buChar char="•"/>
+            </a:pPr>
+            <a:r>
+              <a:rPr lang="es-ES" sz="1200" b="0" i="0" dirty="0">
+                <a:solidFill>
+                  <a:srgbClr val="222222"/>
+                </a:solidFill>
+                <a:effectLst/>
+                <a:latin typeface="Segoe UI" panose="020B0502040204020203" pitchFamily="34" charset="0"/>
+              </a:rPr>
+              <a:t> </a:t>
+            </a:r>
+            <a:r>
+              <a:rPr lang="es-ES" sz="1200" dirty="0">
+                <a:solidFill>
+                  <a:srgbClr val="222222"/>
+                </a:solidFill>
+                <a:latin typeface="Segoe UI" panose="020B0502040204020203" pitchFamily="34" charset="0"/>
+              </a:rPr>
+              <a:t>Se agrego al Reporte de Certificación por hora que los</a:t>
+            </a:r>
+            <a:r>
+              <a:rPr lang="es-ES" sz="1200" b="1" dirty="0">
+                <a:solidFill>
+                  <a:srgbClr val="222222"/>
+                </a:solidFill>
+                <a:latin typeface="Segoe UI" panose="020B0502040204020203" pitchFamily="34" charset="0"/>
+              </a:rPr>
+              <a:t> defectos críticos se pinten en color rojo para identificarlos.</a:t>
+            </a:r>
+            <a:endParaRPr lang="es-ES" sz="1200" b="0" i="0" dirty="0">
+              <a:solidFill>
+                <a:srgbClr val="222222"/>
+              </a:solidFill>
+              <a:effectLst/>
+              <a:latin typeface="Segoe UI" panose="020B0502040204020203" pitchFamily="34" charset="0"/>
+            </a:endParaRPr>
+          </a:p>
+        </p:txBody>
+      </p:sp>
+      <p:pic>
+        <p:nvPicPr>
+          <p:cNvPr id="5" name="Imagen 4">
+            <a:extLst>
+              <a:ext uri="{FF2B5EF4-FFF2-40B4-BE49-F238E27FC236}">
+                <a16:creationId xmlns:a16="http://schemas.microsoft.com/office/drawing/2014/main" id="{7DCFCA07-2801-4EEC-B121-37C013B97E64}"/>
+              </a:ext>
+            </a:extLst>
+          </p:cNvPr>
+          <p:cNvPicPr>
+            <a:picLocks noChangeAspect="1"/>
+          </p:cNvPicPr>
+          <p:nvPr/>
+        </p:nvPicPr>
+        <p:blipFill>
+          <a:blip r:embed="rId2"/>
+          <a:stretch>
+            <a:fillRect/>
+          </a:stretch>
+        </p:blipFill>
+        <p:spPr>
+          <a:xfrm>
+            <a:off x="1403649" y="1556798"/>
+            <a:ext cx="7488831" cy="5256578"/>
+          </a:xfrm>
+          <a:prstGeom prst="rect">
+            <a:avLst/>
+          </a:prstGeom>
+        </p:spPr>
+      </p:pic>
+    </p:spTree>
+    <p:extLst>
+      <p:ext uri="{BB962C8B-B14F-4D97-AF65-F5344CB8AC3E}">
+        <p14:creationId xmlns:p14="http://schemas.microsoft.com/office/powerpoint/2010/main" val="3257233852"/>
+      </p:ext>
+    </p:extLst>
+  </p:cSld>
+  <p:clrMapOvr>
+    <a:masterClrMapping/>
+  </p:clrMapOvr>
+</p:sld>
+</file>
+
+<file path=ppt/slides/slide4.xml><?xml version="1.0" encoding="utf-8"?>
+<p:sld xmlns:a="http://schemas.openxmlformats.org/drawingml/2006/main" xmlns:r="http://schemas.openxmlformats.org/officeDocument/2006/relationships" xmlns:p="http://schemas.openxmlformats.org/presentationml/2006/main">
+  <p:cSld>
+    <p:spTree>
+      <p:nvGrpSpPr>
+        <p:cNvPr id="1" name=""/>
+        <p:cNvGrpSpPr/>
+        <p:nvPr/>
+      </p:nvGrpSpPr>
+      <p:grpSpPr>
+        <a:xfrm>
+          <a:off x="0" y="0"/>
+          <a:ext cx="0" cy="0"/>
+          <a:chOff x="0" y="0"/>
+          <a:chExt cx="0" cy="0"/>
+        </a:xfrm>
+      </p:grpSpPr>
+      <p:sp>
+        <p:nvSpPr>
+          <p:cNvPr id="8" name="Title 1"/>
+          <p:cNvSpPr txBox="1">
+            <a:spLocks/>
+          </p:cNvSpPr>
+          <p:nvPr/>
+        </p:nvSpPr>
+        <p:spPr>
+          <a:xfrm>
+            <a:off x="1087408" y="274638"/>
+            <a:ext cx="7229008" cy="634082"/>
+          </a:xfrm>
+          <a:prstGeom prst="rect">
+            <a:avLst/>
+          </a:prstGeom>
+        </p:spPr>
+        <p:txBody>
+          <a:bodyPr/>
+          <a:lstStyle>
+            <a:lvl1pPr algn="ctr" defTabSz="914400" rtl="0" eaLnBrk="1" latinLnBrk="0" hangingPunct="1">
+              <a:spcBef>
+                <a:spcPct val="0"/>
+              </a:spcBef>
+              <a:buNone/>
+              <a:defRPr sz="4400" kern="1200">
+                <a:solidFill>
+                  <a:schemeClr val="tx1"/>
+                </a:solidFill>
+                <a:latin typeface="+mj-lt"/>
+                <a:ea typeface="+mj-ea"/>
+                <a:cs typeface="+mj-cs"/>
+              </a:defRPr>
+            </a:lvl1pPr>
+          </a:lstStyle>
+          <a:p>
+            <a:pPr algn="l"/>
+            <a:r>
+              <a:rPr lang="es-ES" sz="2000" dirty="0">
+                <a:solidFill>
+                  <a:srgbClr val="3F1900"/>
+                </a:solidFill>
+              </a:rPr>
+              <a:t>QC: Pantalla Certification Report.</a:t>
+            </a:r>
+            <a:endParaRPr lang="en-US" sz="2000" dirty="0">
+              <a:solidFill>
+                <a:srgbClr val="3F1900"/>
+              </a:solidFill>
+            </a:endParaRPr>
+          </a:p>
+        </p:txBody>
+      </p:sp>
+      <p:sp>
+        <p:nvSpPr>
+          <p:cNvPr id="4" name="Content Placeholder 3"/>
+          <p:cNvSpPr txBox="1">
+            <a:spLocks/>
+          </p:cNvSpPr>
+          <p:nvPr/>
+        </p:nvSpPr>
+        <p:spPr>
+          <a:xfrm>
+            <a:off x="1331640" y="1196753"/>
+            <a:ext cx="7488832" cy="5137780"/>
+          </a:xfrm>
+          <a:prstGeom prst="rect">
+            <a:avLst/>
+          </a:prstGeom>
+        </p:spPr>
+        <p:txBody>
+          <a:bodyPr>
+            <a:normAutofit/>
+          </a:bodyPr>
+          <a:lstStyle>
+            <a:lvl1pPr marL="342900" indent="-342900" algn="l" defTabSz="914400" rtl="0" eaLnBrk="1" latinLnBrk="0" hangingPunct="1">
+              <a:spcBef>
+                <a:spcPct val="20000"/>
+              </a:spcBef>
+              <a:buFont typeface="Arial" panose="020B0604020202020204" pitchFamily="34" charset="0"/>
+              <a:buChar char="•"/>
+              <a:defRPr sz="3200" kern="1200">
+                <a:solidFill>
+                  <a:schemeClr val="tx1"/>
+                </a:solidFill>
+                <a:latin typeface="+mn-lt"/>
+                <a:ea typeface="+mn-ea"/>
+                <a:cs typeface="+mn-cs"/>
+              </a:defRPr>
+            </a:lvl1pPr>
+            <a:lvl2pPr marL="742950" indent="-285750" algn="l" defTabSz="914400" rtl="0" eaLnBrk="1" latinLnBrk="0" hangingPunct="1">
+              <a:spcBef>
+                <a:spcPct val="20000"/>
+              </a:spcBef>
+              <a:buFont typeface="Arial" panose="020B0604020202020204" pitchFamily="34" charset="0"/>
+              <a:buChar char="–"/>
+              <a:defRPr sz="2800" kern="1200">
+                <a:solidFill>
+                  <a:schemeClr val="tx1"/>
+                </a:solidFill>
+                <a:latin typeface="+mn-lt"/>
+                <a:ea typeface="+mn-ea"/>
+                <a:cs typeface="+mn-cs"/>
+              </a:defRPr>
+            </a:lvl2pPr>
+            <a:lvl3pPr marL="1143000" indent="-228600" algn="l" defTabSz="914400" rtl="0" eaLnBrk="1" latinLnBrk="0" hangingPunct="1">
+              <a:spcBef>
+                <a:spcPct val="20000"/>
+              </a:spcBef>
+              <a:buFont typeface="Arial" panose="020B0604020202020204" pitchFamily="34" charset="0"/>
+              <a:buChar char="•"/>
+              <a:defRPr sz="2400" kern="1200">
+                <a:solidFill>
+                  <a:schemeClr val="tx1"/>
+                </a:solidFill>
+                <a:latin typeface="+mn-lt"/>
+                <a:ea typeface="+mn-ea"/>
+                <a:cs typeface="+mn-cs"/>
+              </a:defRPr>
+            </a:lvl3pPr>
+            <a:lvl4pPr marL="1600200" indent="-228600" algn="l" defTabSz="914400" rtl="0" eaLnBrk="1" latinLnBrk="0" hangingPunct="1">
+              <a:spcBef>
+                <a:spcPct val="20000"/>
+              </a:spcBef>
+              <a:buFont typeface="Arial" panose="020B0604020202020204" pitchFamily="34" charset="0"/>
+              <a:buChar char="–"/>
+              <a:defRPr sz="2000" kern="1200">
+                <a:solidFill>
+                  <a:schemeClr val="tx1"/>
+                </a:solidFill>
+                <a:latin typeface="+mn-lt"/>
+                <a:ea typeface="+mn-ea"/>
+                <a:cs typeface="+mn-cs"/>
+              </a:defRPr>
+            </a:lvl4pPr>
+            <a:lvl5pPr marL="2057400" indent="-228600" algn="l" defTabSz="914400" rtl="0" eaLnBrk="1" latinLnBrk="0" hangingPunct="1">
+              <a:spcBef>
+                <a:spcPct val="20000"/>
+              </a:spcBef>
+              <a:buFont typeface="Arial" panose="020B0604020202020204" pitchFamily="34" charset="0"/>
+              <a:buChar char="»"/>
+              <a:defRPr sz="2000" kern="1200">
+                <a:solidFill>
+                  <a:schemeClr val="tx1"/>
+                </a:solidFill>
+                <a:latin typeface="+mn-lt"/>
+                <a:ea typeface="+mn-ea"/>
+                <a:cs typeface="+mn-cs"/>
+              </a:defRPr>
+            </a:lvl5pPr>
+            <a:lvl6pPr marL="2514600" indent="-228600" algn="l" defTabSz="914400" rtl="0" eaLnBrk="1" latinLnBrk="0" hangingPunct="1">
+              <a:spcBef>
+                <a:spcPct val="20000"/>
+              </a:spcBef>
+              <a:buFont typeface="Arial" panose="020B0604020202020204" pitchFamily="34" charset="0"/>
+              <a:buChar char="•"/>
+              <a:defRPr sz="2000" kern="1200">
+                <a:solidFill>
+                  <a:schemeClr val="tx1"/>
+                </a:solidFill>
+                <a:latin typeface="+mn-lt"/>
+                <a:ea typeface="+mn-ea"/>
+                <a:cs typeface="+mn-cs"/>
+              </a:defRPr>
+            </a:lvl6pPr>
+            <a:lvl7pPr marL="2971800" indent="-228600" algn="l" defTabSz="914400" rtl="0" eaLnBrk="1" latinLnBrk="0" hangingPunct="1">
+              <a:spcBef>
+                <a:spcPct val="20000"/>
+              </a:spcBef>
+              <a:buFont typeface="Arial" panose="020B0604020202020204" pitchFamily="34" charset="0"/>
+              <a:buChar char="•"/>
+              <a:defRPr sz="2000" kern="1200">
+                <a:solidFill>
+                  <a:schemeClr val="tx1"/>
+                </a:solidFill>
+                <a:latin typeface="+mn-lt"/>
+                <a:ea typeface="+mn-ea"/>
+                <a:cs typeface="+mn-cs"/>
+              </a:defRPr>
+            </a:lvl7pPr>
+            <a:lvl8pPr marL="3429000" indent="-228600" algn="l" defTabSz="914400" rtl="0" eaLnBrk="1" latinLnBrk="0" hangingPunct="1">
+              <a:spcBef>
+                <a:spcPct val="20000"/>
+              </a:spcBef>
+              <a:buFont typeface="Arial" panose="020B0604020202020204" pitchFamily="34" charset="0"/>
+              <a:buChar char="•"/>
+              <a:defRPr sz="2000" kern="1200">
+                <a:solidFill>
+                  <a:schemeClr val="tx1"/>
+                </a:solidFill>
+                <a:latin typeface="+mn-lt"/>
+                <a:ea typeface="+mn-ea"/>
+                <a:cs typeface="+mn-cs"/>
+              </a:defRPr>
+            </a:lvl8pPr>
+            <a:lvl9pPr marL="3886200" indent="-228600" algn="l" defTabSz="914400" rtl="0" eaLnBrk="1" latinLnBrk="0" hangingPunct="1">
+              <a:spcBef>
+                <a:spcPct val="20000"/>
+              </a:spcBef>
+              <a:buFont typeface="Arial" panose="020B0604020202020204" pitchFamily="34" charset="0"/>
+              <a:buChar char="•"/>
+              <a:defRPr sz="2000" kern="1200">
+                <a:solidFill>
+                  <a:schemeClr val="tx1"/>
+                </a:solidFill>
+                <a:latin typeface="+mn-lt"/>
+                <a:ea typeface="+mn-ea"/>
+                <a:cs typeface="+mn-cs"/>
+              </a:defRPr>
+            </a:lvl9pPr>
+          </a:lstStyle>
+          <a:p>
+            <a:pPr marL="0" indent="0" algn="just">
+              <a:buFont typeface="Arial" panose="020B0604020202020204" pitchFamily="34" charset="0"/>
+              <a:buNone/>
+            </a:pPr>
+            <a:endParaRPr lang="en-US" sz="2000" i="1"/>
+          </a:p>
+        </p:txBody>
+      </p:sp>
+      <p:sp>
+        <p:nvSpPr>
+          <p:cNvPr id="10" name="Rectangle 9"/>
+          <p:cNvSpPr/>
+          <p:nvPr/>
+        </p:nvSpPr>
+        <p:spPr>
+          <a:xfrm>
+            <a:off x="1187624" y="1095133"/>
+            <a:ext cx="7776864" cy="461665"/>
+          </a:xfrm>
+          <a:prstGeom prst="rect">
+            <a:avLst/>
+          </a:prstGeom>
+        </p:spPr>
+        <p:txBody>
+          <a:bodyPr wrap="square">
+            <a:spAutoFit/>
+          </a:bodyPr>
+          <a:lstStyle/>
+          <a:p>
+            <a:pPr>
+              <a:buFont typeface="Arial" panose="020B0604020202020204" pitchFamily="34" charset="0"/>
+              <a:buChar char="•"/>
+            </a:pPr>
+            <a:r>
+              <a:rPr lang="es-ES" sz="1200" b="0" i="0" dirty="0">
+                <a:solidFill>
+                  <a:srgbClr val="222222"/>
+                </a:solidFill>
+                <a:effectLst/>
+                <a:latin typeface="Segoe UI" panose="020B0502040204020203" pitchFamily="34" charset="0"/>
+              </a:rPr>
+              <a:t> </a:t>
+            </a:r>
+            <a:r>
+              <a:rPr lang="es-ES" sz="1200" dirty="0">
+                <a:solidFill>
+                  <a:srgbClr val="222222"/>
+                </a:solidFill>
+                <a:latin typeface="Segoe UI" panose="020B0502040204020203" pitchFamily="34" charset="0"/>
+              </a:rPr>
+              <a:t>Se agrego al reporte de certificación en la sección de administrar defecto, la opción para poder capturar la traducción a ingles del defecto y especificar si es critico.</a:t>
+            </a:r>
+            <a:endParaRPr lang="es-ES" sz="1200" i="0" dirty="0">
+              <a:solidFill>
+                <a:srgbClr val="222222"/>
+              </a:solidFill>
+              <a:effectLst/>
+              <a:latin typeface="Segoe UI" panose="020B0502040204020203" pitchFamily="34" charset="0"/>
+            </a:endParaRPr>
+          </a:p>
+        </p:txBody>
+      </p:sp>
+      <p:pic>
+        <p:nvPicPr>
+          <p:cNvPr id="3" name="Imagen 2">
+            <a:extLst>
+              <a:ext uri="{FF2B5EF4-FFF2-40B4-BE49-F238E27FC236}">
+                <a16:creationId xmlns:a16="http://schemas.microsoft.com/office/drawing/2014/main" id="{860C153F-C327-4618-B028-9A4BD6E5388E}"/>
+              </a:ext>
+            </a:extLst>
+          </p:cNvPr>
+          <p:cNvPicPr>
+            <a:picLocks noChangeAspect="1"/>
+          </p:cNvPicPr>
+          <p:nvPr/>
+        </p:nvPicPr>
+        <p:blipFill rotWithShape="1">
+          <a:blip r:embed="rId2"/>
+          <a:srcRect l="1" r="506" b="841"/>
+          <a:stretch/>
+        </p:blipFill>
+        <p:spPr>
+          <a:xfrm>
+            <a:off x="1187624" y="1556799"/>
+            <a:ext cx="7848872" cy="5256578"/>
+          </a:xfrm>
+          <a:prstGeom prst="rect">
+            <a:avLst/>
+          </a:prstGeom>
+        </p:spPr>
+      </p:pic>
+      <p:sp>
+        <p:nvSpPr>
+          <p:cNvPr id="6" name="Rectángulo 5">
+            <a:extLst>
+              <a:ext uri="{FF2B5EF4-FFF2-40B4-BE49-F238E27FC236}">
+                <a16:creationId xmlns:a16="http://schemas.microsoft.com/office/drawing/2014/main" id="{F812EC2A-2C3F-4048-B8DB-456F0B9C36E9}"/>
+              </a:ext>
+            </a:extLst>
+          </p:cNvPr>
+          <p:cNvSpPr/>
+          <p:nvPr/>
+        </p:nvSpPr>
+        <p:spPr>
+          <a:xfrm>
+            <a:off x="5580112" y="2708920"/>
+            <a:ext cx="1800200" cy="432047"/>
+          </a:xfrm>
+          <a:prstGeom prst="rect">
+            <a:avLst/>
+          </a:prstGeom>
+          <a:noFill/>
+          <a:ln>
+            <a:solidFill>
+              <a:srgbClr val="FF0000"/>
+            </a:solidFill>
+          </a:ln>
+        </p:spPr>
+        <p:style>
+          <a:lnRef idx="2">
+            <a:schemeClr val="accent1">
+              <a:shade val="50000"/>
+            </a:schemeClr>
+          </a:lnRef>
+          <a:fillRef idx="1">
+            <a:schemeClr val="accent1"/>
+          </a:fillRef>
+          <a:effectRef idx="0">
+            <a:schemeClr val="accent1"/>
+          </a:effectRef>
+          <a:fontRef idx="minor">
+            <a:schemeClr val="lt1"/>
+          </a:fontRef>
+        </p:style>
+        <p:txBody>
+          <a:bodyPr rtlCol="0" anchor="ctr"/>
+          <a:lstStyle/>
+          <a:p>
+            <a:pPr algn="ctr"/>
+            <a:endParaRPr lang="en-US"/>
+          </a:p>
+        </p:txBody>
+      </p:sp>
+    </p:spTree>
+    <p:extLst>
+      <p:ext uri="{BB962C8B-B14F-4D97-AF65-F5344CB8AC3E}">
+        <p14:creationId xmlns:p14="http://schemas.microsoft.com/office/powerpoint/2010/main" val="3600767166"/>
+      </p:ext>
+    </p:extLst>
+  </p:cSld>
+  <p:clrMapOvr>
+    <a:masterClrMapping/>
+  </p:clrMapOvr>
+</p:sld>
+</file>
+
+<file path=ppt/slides/slide5.xml><?xml version="1.0" encoding="utf-8"?>
+<p:sld xmlns:a="http://schemas.openxmlformats.org/drawingml/2006/main" xmlns:r="http://schemas.openxmlformats.org/officeDocument/2006/relationships" xmlns:p="http://schemas.openxmlformats.org/presentationml/2006/main">
+  <p:cSld>
+    <p:spTree>
+      <p:nvGrpSpPr>
+        <p:cNvPr id="1" name=""/>
+        <p:cNvGrpSpPr/>
+        <p:nvPr/>
+      </p:nvGrpSpPr>
+      <p:grpSpPr>
+        <a:xfrm>
+          <a:off x="0" y="0"/>
+          <a:ext cx="0" cy="0"/>
+          <a:chOff x="0" y="0"/>
+          <a:chExt cx="0" cy="0"/>
+        </a:xfrm>
+      </p:grpSpPr>
+      <p:sp>
+        <p:nvSpPr>
+          <p:cNvPr id="5" name="Title 1"/>
+          <p:cNvSpPr txBox="1">
+            <a:spLocks/>
+          </p:cNvSpPr>
+          <p:nvPr/>
+        </p:nvSpPr>
+        <p:spPr>
+          <a:xfrm>
+            <a:off x="1187624" y="2564904"/>
+            <a:ext cx="7772400" cy="1470025"/>
+          </a:xfrm>
+          <a:prstGeom prst="rect">
+            <a:avLst/>
+          </a:prstGeom>
+        </p:spPr>
+        <p:txBody>
+          <a:bodyPr vert="horz" lIns="91440" tIns="45720" rIns="91440" bIns="45720" rtlCol="0" anchor="ctr">
+            <a:normAutofit/>
+          </a:bodyPr>
+          <a:lstStyle>
+            <a:lvl1pPr algn="ctr" defTabSz="914400" rtl="0" eaLnBrk="1" latinLnBrk="0" hangingPunct="1">
+              <a:spcBef>
+                <a:spcPct val="0"/>
+              </a:spcBef>
+              <a:buNone/>
+              <a:defRPr sz="4400" kern="1200">
+                <a:solidFill>
+                  <a:schemeClr val="tx1"/>
+                </a:solidFill>
+                <a:latin typeface="+mj-lt"/>
+                <a:ea typeface="+mj-ea"/>
+                <a:cs typeface="+mj-cs"/>
+              </a:defRPr>
+            </a:lvl1pPr>
+          </a:lstStyle>
+          <a:p>
+            <a:r>
+              <a:rPr lang="es-MX" b="1" dirty="0">
+                <a:latin typeface="Century Gothic" panose="020B0502020202020204" pitchFamily="34" charset="0"/>
+              </a:rPr>
+              <a:t>04/10/2021 – 08/10/2021</a:t>
+            </a:r>
+            <a:endParaRPr lang="es-MX" dirty="0">
+              <a:latin typeface="Century Gothic" panose="020B0502020202020204" pitchFamily="34" charset="0"/>
+            </a:endParaRPr>
+          </a:p>
+        </p:txBody>
+      </p:sp>
+    </p:spTree>
+    <p:extLst>
+      <p:ext uri="{BB962C8B-B14F-4D97-AF65-F5344CB8AC3E}">
+        <p14:creationId xmlns:p14="http://schemas.microsoft.com/office/powerpoint/2010/main" val="2720907003"/>
+      </p:ext>
+    </p:extLst>
+  </p:cSld>
+  <p:clrMapOvr>
+    <a:masterClrMapping/>
+  </p:clrMapOvr>
+</p:sld>
+</file>
+
+<file path=ppt/slides/slide6.xml><?xml version="1.0" encoding="utf-8"?>
 <p:sld xmlns:a="http://schemas.openxmlformats.org/drawingml/2006/main" xmlns:r="http://schemas.openxmlformats.org/officeDocument/2006/relationships" xmlns:p="http://schemas.openxmlformats.org/presentationml/2006/main">
   <p:cSld>
     <p:spTree>
@@ -3875,7 +5030,7 @@
     </p:spTree>
     <p:extLst>
       <p:ext uri="{BB962C8B-B14F-4D97-AF65-F5344CB8AC3E}">
-        <p14:creationId xmlns:p14="http://schemas.microsoft.com/office/powerpoint/2010/main" val="3323146812"/>
+        <p14:creationId xmlns:p14="http://schemas.microsoft.com/office/powerpoint/2010/main" val="1820524178"/>
       </p:ext>
     </p:extLst>
   </p:cSld>
@@ -3885,7 +5040,7 @@
 </p:sld>
 </file>
 
-<file path=ppt/slides/slide3.xml><?xml version="1.0" encoding="utf-8"?>
+<file path=ppt/slides/slide7.xml><?xml version="1.0" encoding="utf-8"?>
 <p:sld xmlns:a="http://schemas.openxmlformats.org/drawingml/2006/main" xmlns:r="http://schemas.openxmlformats.org/officeDocument/2006/relationships" xmlns:p="http://schemas.openxmlformats.org/presentationml/2006/main">
   <p:cSld>
     <p:spTree>
@@ -3965,7 +5120,7 @@
 </p:sld>
 </file>
 
-<file path=ppt/slides/slide4.xml><?xml version="1.0" encoding="utf-8"?>
+<file path=ppt/slides/slide8.xml><?xml version="1.0" encoding="utf-8"?>
 <p:sld xmlns:a="http://schemas.openxmlformats.org/drawingml/2006/main" xmlns:r="http://schemas.openxmlformats.org/officeDocument/2006/relationships" xmlns:p="http://schemas.openxmlformats.org/presentationml/2006/main">
   <p:cSld>
     <p:spTree>

</xml_diff>